<commit_message>
14th commit - Acer Updates
</commit_message>
<xml_diff>
--- a/DevOPS/2026/Manual_Docs/AZURE/Presentation1.pptx
+++ b/DevOPS/2026/Manual_Docs/AZURE/Presentation1.pptx
@@ -271,7 +271,7 @@
           <a:p>
             <a:fld id="{320C8B9A-83CF-42B5-9B24-31E16522E221}" type="datetimeFigureOut">
               <a:rPr lang="en-IN" smtClean="0"/>
-              <a:t>14-03-2026</a:t>
+              <a:t>29-03-2026</a:t>
             </a:fld>
             <a:endParaRPr lang="en-IN"/>
           </a:p>
@@ -471,7 +471,7 @@
           <a:p>
             <a:fld id="{320C8B9A-83CF-42B5-9B24-31E16522E221}" type="datetimeFigureOut">
               <a:rPr lang="en-IN" smtClean="0"/>
-              <a:t>14-03-2026</a:t>
+              <a:t>29-03-2026</a:t>
             </a:fld>
             <a:endParaRPr lang="en-IN"/>
           </a:p>
@@ -681,7 +681,7 @@
           <a:p>
             <a:fld id="{320C8B9A-83CF-42B5-9B24-31E16522E221}" type="datetimeFigureOut">
               <a:rPr lang="en-IN" smtClean="0"/>
-              <a:t>14-03-2026</a:t>
+              <a:t>29-03-2026</a:t>
             </a:fld>
             <a:endParaRPr lang="en-IN"/>
           </a:p>
@@ -881,7 +881,7 @@
           <a:p>
             <a:fld id="{320C8B9A-83CF-42B5-9B24-31E16522E221}" type="datetimeFigureOut">
               <a:rPr lang="en-IN" smtClean="0"/>
-              <a:t>14-03-2026</a:t>
+              <a:t>29-03-2026</a:t>
             </a:fld>
             <a:endParaRPr lang="en-IN"/>
           </a:p>
@@ -1157,7 +1157,7 @@
           <a:p>
             <a:fld id="{320C8B9A-83CF-42B5-9B24-31E16522E221}" type="datetimeFigureOut">
               <a:rPr lang="en-IN" smtClean="0"/>
-              <a:t>14-03-2026</a:t>
+              <a:t>29-03-2026</a:t>
             </a:fld>
             <a:endParaRPr lang="en-IN"/>
           </a:p>
@@ -1425,7 +1425,7 @@
           <a:p>
             <a:fld id="{320C8B9A-83CF-42B5-9B24-31E16522E221}" type="datetimeFigureOut">
               <a:rPr lang="en-IN" smtClean="0"/>
-              <a:t>14-03-2026</a:t>
+              <a:t>29-03-2026</a:t>
             </a:fld>
             <a:endParaRPr lang="en-IN"/>
           </a:p>
@@ -1840,7 +1840,7 @@
           <a:p>
             <a:fld id="{320C8B9A-83CF-42B5-9B24-31E16522E221}" type="datetimeFigureOut">
               <a:rPr lang="en-IN" smtClean="0"/>
-              <a:t>14-03-2026</a:t>
+              <a:t>29-03-2026</a:t>
             </a:fld>
             <a:endParaRPr lang="en-IN"/>
           </a:p>
@@ -1982,7 +1982,7 @@
           <a:p>
             <a:fld id="{320C8B9A-83CF-42B5-9B24-31E16522E221}" type="datetimeFigureOut">
               <a:rPr lang="en-IN" smtClean="0"/>
-              <a:t>14-03-2026</a:t>
+              <a:t>29-03-2026</a:t>
             </a:fld>
             <a:endParaRPr lang="en-IN"/>
           </a:p>
@@ -2095,7 +2095,7 @@
           <a:p>
             <a:fld id="{320C8B9A-83CF-42B5-9B24-31E16522E221}" type="datetimeFigureOut">
               <a:rPr lang="en-IN" smtClean="0"/>
-              <a:t>14-03-2026</a:t>
+              <a:t>29-03-2026</a:t>
             </a:fld>
             <a:endParaRPr lang="en-IN"/>
           </a:p>
@@ -2408,7 +2408,7 @@
           <a:p>
             <a:fld id="{320C8B9A-83CF-42B5-9B24-31E16522E221}" type="datetimeFigureOut">
               <a:rPr lang="en-IN" smtClean="0"/>
-              <a:t>14-03-2026</a:t>
+              <a:t>29-03-2026</a:t>
             </a:fld>
             <a:endParaRPr lang="en-IN"/>
           </a:p>
@@ -2697,7 +2697,7 @@
           <a:p>
             <a:fld id="{320C8B9A-83CF-42B5-9B24-31E16522E221}" type="datetimeFigureOut">
               <a:rPr lang="en-IN" smtClean="0"/>
-              <a:t>14-03-2026</a:t>
+              <a:t>29-03-2026</a:t>
             </a:fld>
             <a:endParaRPr lang="en-IN"/>
           </a:p>
@@ -2940,7 +2940,7 @@
           <a:p>
             <a:fld id="{320C8B9A-83CF-42B5-9B24-31E16522E221}" type="datetimeFigureOut">
               <a:rPr lang="en-IN" smtClean="0"/>
-              <a:t>14-03-2026</a:t>
+              <a:t>29-03-2026</a:t>
             </a:fld>
             <a:endParaRPr lang="en-IN"/>
           </a:p>
@@ -3777,6 +3777,36 @@
           <a:chExt cx="0" cy="0"/>
         </a:xfrm>
       </p:grpSpPr>
+      <p:pic>
+        <p:nvPicPr>
+          <p:cNvPr id="3" name="Picture 2">
+            <a:extLst>
+              <a:ext uri="{FF2B5EF4-FFF2-40B4-BE49-F238E27FC236}">
+                <a16:creationId xmlns:a16="http://schemas.microsoft.com/office/drawing/2014/main" id="{B19DEEBB-21D6-7DF6-1BC5-C55F7CF0F670}"/>
+              </a:ext>
+            </a:extLst>
+          </p:cNvPr>
+          <p:cNvPicPr>
+            <a:picLocks noChangeAspect="1"/>
+          </p:cNvPicPr>
+          <p:nvPr/>
+        </p:nvPicPr>
+        <p:blipFill>
+          <a:blip r:embed="rId2"/>
+          <a:stretch>
+            <a:fillRect/>
+          </a:stretch>
+        </p:blipFill>
+        <p:spPr>
+          <a:xfrm>
+            <a:off x="1974484" y="0"/>
+            <a:ext cx="8243031" cy="6858000"/>
+          </a:xfrm>
+          <a:prstGeom prst="rect">
+            <a:avLst/>
+          </a:prstGeom>
+        </p:spPr>
+      </p:pic>
     </p:spTree>
     <p:extLst>
       <p:ext uri="{BB962C8B-B14F-4D97-AF65-F5344CB8AC3E}">
@@ -3807,6 +3837,36 @@
           <a:chExt cx="0" cy="0"/>
         </a:xfrm>
       </p:grpSpPr>
+      <p:pic>
+        <p:nvPicPr>
+          <p:cNvPr id="3" name="Picture 2">
+            <a:extLst>
+              <a:ext uri="{FF2B5EF4-FFF2-40B4-BE49-F238E27FC236}">
+                <a16:creationId xmlns:a16="http://schemas.microsoft.com/office/drawing/2014/main" id="{7FC650CD-D4D8-0B0B-3A6D-C8811634C7CA}"/>
+              </a:ext>
+            </a:extLst>
+          </p:cNvPr>
+          <p:cNvPicPr>
+            <a:picLocks noChangeAspect="1"/>
+          </p:cNvPicPr>
+          <p:nvPr/>
+        </p:nvPicPr>
+        <p:blipFill>
+          <a:blip r:embed="rId2"/>
+          <a:stretch>
+            <a:fillRect/>
+          </a:stretch>
+        </p:blipFill>
+        <p:spPr>
+          <a:xfrm>
+            <a:off x="299256" y="0"/>
+            <a:ext cx="11593488" cy="6858000"/>
+          </a:xfrm>
+          <a:prstGeom prst="rect">
+            <a:avLst/>
+          </a:prstGeom>
+        </p:spPr>
+      </p:pic>
     </p:spTree>
     <p:extLst>
       <p:ext uri="{BB962C8B-B14F-4D97-AF65-F5344CB8AC3E}">

</xml_diff>